<commit_message>
Polish portfolio index slide to match PLRA reference style
Center system names on index cards and align card chrome with the
Assigned Project Portfolio reference layout.

Co-authored-by: Gulraiz Ahmed <GulraizAhmed@users.noreply.github.com>
</commit_message>
<xml_diff>
--- a/PLRA_Assigned_Project_Portfolio_Status.pptx
+++ b/PLRA_Assigned_Project_Portfolio_Status.pptx
@@ -11284,7 +11284,7 @@
                 </a:solidFill>
                 <a:latin typeface="Calibri"/>
               </a:rPr>
-              <a:t>•  </a:t>
+              <a:t>•  Future: Digital Exam Portal with HRMS elevation exams</a:t>
             </a:r>
           </a:p>
           <a:p>
@@ -11303,7 +11303,7 @@
                 </a:solidFill>
                 <a:latin typeface="Calibri"/>
               </a:rPr>
-              <a:t>•  Future — Digital Examination Portal</a:t>
+              <a:t>•  Biometric verification, secure Q-bank, CBT &amp; auto evaluation</a:t>
             </a:r>
           </a:p>
           <a:p>
@@ -11322,45 +11322,7 @@
                 </a:solidFill>
                 <a:latin typeface="Calibri"/>
               </a:rPr>
-              <a:t>•  HRMS-linked elevation exams, biometric verification</a:t>
-            </a:r>
-          </a:p>
-          <a:p>
-            <a:pPr algn="l">
-              <a:spcBef>
-                <a:spcPts val="0"/>
-              </a:spcBef>
-              <a:spcAft>
-                <a:spcPts val="100"/>
-              </a:spcAft>
-            </a:pPr>
-            <a:r>
-              <a:rPr sz="1000" b="0" i="0">
-                <a:solidFill>
-                  <a:srgbClr val="222222"/>
-                </a:solidFill>
-                <a:latin typeface="Calibri"/>
-              </a:rPr>
-              <a:t>•  Secure question bank, CBT &amp; randomized papers</a:t>
-            </a:r>
-          </a:p>
-          <a:p>
-            <a:pPr algn="l">
-              <a:spcBef>
-                <a:spcPts val="0"/>
-              </a:spcBef>
-              <a:spcAft>
-                <a:spcPts val="100"/>
-              </a:spcAft>
-            </a:pPr>
-            <a:r>
-              <a:rPr sz="1000" b="0" i="0">
-                <a:solidFill>
-                  <a:srgbClr val="222222"/>
-                </a:solidFill>
-                <a:latin typeface="Calibri"/>
-              </a:rPr>
-              <a:t>•  Auto evaluation, HR/committee workflow, MPDD training</a:t>
+              <a:t>•  HR/committee workflow; MPDD post-elevation training</a:t>
             </a:r>
           </a:p>
         </p:txBody>

</xml_diff>